<commit_message>
Snow-on-hardware result in deck slide 6, script, HARDWARE_RESULTS and QA; supercomputer answer; ratio 2.7x/3.1x
Co-Authored-By: Claude Opus 5.5 <noreply@anthropic.com>
</commit_message>
<xml_diff>
--- a/deck/Tulva_QxF2026.pptx
+++ b/deck/Tulva_QxF2026.pptx
@@ -890,7 +890,7 @@
           </a:p>
           <a:p>
             <a:r>
-              <a:t>Pricing this cover means estimating one rare joint probability: a job for quantum amplitude estimation. We loaded all fourteen areas onto IQM Emerald, 18 qubits, 44 two-qubit gates, and it reproduced the joint tail. On IBM and IQM, calibrated amplitude estimation landed within 0.04 points of the exact answer.</a:t>
+              <a:t>Pricing means estimating a rare joint probability, a job for quantum amplitude estimation. We loaded all fourteen areas onto IQM Emerald, 18 qubits, 44 two-qubit gates, and it reproduced the joint tail. On IBM and IQM, calibrated estimates landed within 0.04 points of exact, and the chip even reproduced the snow warning: three times the risk after a snowy March.</a:t>
             </a:r>
           </a:p>
         </p:txBody>
@@ -8081,8 +8081,8 @@
         </p:nvSpPr>
         <p:spPr>
           <a:xfrm>
-            <a:off x="7863840" y="5577840"/>
-            <a:ext cx="3794760" cy="365760"/>
+            <a:off x="7863840" y="5486400"/>
+            <a:ext cx="3794760" cy="548640"/>
           </a:xfrm>
           <a:prstGeom prst="rect">
             <a:avLst/>
@@ -8104,13 +8104,22 @@
               </a:spcAft>
             </a:pPr>
             <a:r>
-              <a:rPr sz="1200" b="0">
+              <a:rPr sz="1300" b="1">
                 <a:solidFill>
                   <a:srgbClr val="0B1F3A"/>
                 </a:solidFill>
                 <a:latin typeface="Arial"/>
               </a:rPr>
-              <a:t>Also native Qrisp on IQM Garnet; 20–25 side-by-side copies on IBM.</a:t>
+              <a:t>Snow signal on the chip: </a:t>
+            </a:r>
+            <a:r>
+              <a:rPr sz="1300" b="1">
+                <a:solidFill>
+                  <a:srgbClr val="1F6FEB"/>
+                </a:solidFill>
+                <a:latin typeface="Arial"/>
+              </a:rPr>
+              <a:t>snowy vs low March 3.1× (exact 2.7×)</a:t>
             </a:r>
           </a:p>
         </p:txBody>
@@ -8152,7 +8161,7 @@
                 </a:solidFill>
                 <a:latin typeface="Arial"/>
               </a:rPr>
-              <a:t>IQM Emerald job 01a11cd4…, 8,000 shots; IBM ibm_marrakesh (best-qubit run, 20 copies); IQM Garnet 4 copies, 120k shots</a:t>
+              <a:t>IQM Emerald job 01a11cd4…, 8,000 shots; snow runs: Emerald, 10 copies, 240k shots each; IBM ibm_marrakesh (20 copies); IQM Garnet (4 copies); also native Qrisp on Garnet</a:t>
             </a:r>
           </a:p>
         </p:txBody>

</xml_diff>